<commit_message>
se agrego ejemplo de NES
</commit_message>
<xml_diff>
--- a/presentacion.pptx
+++ b/presentacion.pptx
@@ -16927,6 +16927,61 @@
           </a:p>
         </p:txBody>
       </p:sp>
+      <p:sp>
+        <p:nvSpPr>
+          <p:cNvPr id="94" name="CuadroTexto 93">
+            <a:hlinkClick r:id="rId10"/>
+            <a:extLst>
+              <a:ext uri="{FF2B5EF4-FFF2-40B4-BE49-F238E27FC236}">
+                <a16:creationId xmlns:a16="http://schemas.microsoft.com/office/drawing/2014/main" id="{6BE8C26A-E813-9B29-5D3C-EC64F24D64B1}"/>
+              </a:ext>
+            </a:extLst>
+          </p:cNvPr>
+          <p:cNvSpPr txBox="1"/>
+          <p:nvPr/>
+        </p:nvSpPr>
+        <p:spPr>
+          <a:xfrm>
+            <a:off x="2898718" y="3985165"/>
+            <a:ext cx="1334883" cy="261610"/>
+          </a:xfrm>
+          <a:prstGeom prst="rect">
+            <a:avLst/>
+          </a:prstGeom>
+          <a:noFill/>
+        </p:spPr>
+        <p:txBody>
+          <a:bodyPr wrap="square">
+            <a:spAutoFit/>
+          </a:bodyPr>
+          <a:lstStyle/>
+          <a:p>
+            <a:pPr marL="0" indent="0" algn="ctr">
+              <a:buNone/>
+            </a:pPr>
+            <a:r>
+              <a:rPr lang="es-UY" sz="1050" dirty="0">
+                <a:solidFill>
+                  <a:schemeClr val="accent3"/>
+                </a:solidFill>
+                <a:hlinkClick r:id="rId12">
+                  <a:extLst>
+                    <a:ext uri="{A12FA001-AC4F-418D-AE19-62706E023703}">
+                      <ahyp:hlinkClr xmlns:ahyp="http://schemas.microsoft.com/office/drawing/2018/hyperlinkcolor" val="tx"/>
+                    </a:ext>
+                  </a:extLst>
+                </a:hlinkClick>
+              </a:rPr>
+              <a:t>Video de ejemplo</a:t>
+            </a:r>
+            <a:endParaRPr lang="es-419" sz="1050" noProof="0" dirty="0">
+              <a:solidFill>
+                <a:schemeClr val="accent3"/>
+              </a:solidFill>
+            </a:endParaRPr>
+          </a:p>
+        </p:txBody>
+      </p:sp>
     </p:spTree>
     <p:extLst>
       <p:ext uri="{BB962C8B-B14F-4D97-AF65-F5344CB8AC3E}">

</xml_diff>

<commit_message>
se agregaron tips inline chat
</commit_message>
<xml_diff>
--- a/presentacion.pptx
+++ b/presentacion.pptx
@@ -6633,7 +6633,7 @@
         </p:nvSpPr>
         <p:spPr>
           <a:xfrm>
-            <a:off x="330669" y="2867356"/>
+            <a:off x="330669" y="2992969"/>
             <a:ext cx="4241331" cy="1507526"/>
           </a:xfrm>
           <a:prstGeom prst="rect">
@@ -6755,8 +6755,8 @@
         </p:nvSpPr>
         <p:spPr>
           <a:xfrm>
-            <a:off x="262520" y="1274921"/>
-            <a:ext cx="3055841" cy="1448730"/>
+            <a:off x="262520" y="974595"/>
+            <a:ext cx="4423780" cy="1171731"/>
           </a:xfrm>
           <a:prstGeom prst="rect">
             <a:avLst/>
@@ -6900,7 +6900,7 @@
         </p:nvSpPr>
         <p:spPr>
           <a:xfrm>
-            <a:off x="804780" y="969936"/>
+            <a:off x="1636296" y="739306"/>
             <a:ext cx="1630075" cy="307777"/>
           </a:xfrm>
           <a:prstGeom prst="rect">
@@ -7314,7 +7314,7 @@
         </p:nvSpPr>
         <p:spPr>
           <a:xfrm>
-            <a:off x="262520" y="4518588"/>
+            <a:off x="262520" y="4644201"/>
             <a:ext cx="4572000" cy="276999"/>
           </a:xfrm>
           <a:prstGeom prst="rect">
@@ -7377,7 +7377,7 @@
         </p:nvSpPr>
         <p:spPr>
           <a:xfrm>
-            <a:off x="433909" y="3041474"/>
+            <a:off x="433909" y="3167087"/>
             <a:ext cx="2540905" cy="705258"/>
           </a:xfrm>
           <a:prstGeom prst="rect">
@@ -7442,7 +7442,7 @@
         </p:blipFill>
         <p:spPr>
           <a:xfrm>
-            <a:off x="3169186" y="3016897"/>
+            <a:off x="3169186" y="3142510"/>
             <a:ext cx="1208443" cy="1208443"/>
           </a:xfrm>
           <a:prstGeom prst="rect">
@@ -7450,6 +7450,158 @@
           </a:prstGeom>
         </p:spPr>
       </p:pic>
+      <p:sp>
+        <p:nvSpPr>
+          <p:cNvPr id="6" name="CuadroTexto 5">
+            <a:extLst>
+              <a:ext uri="{FF2B5EF4-FFF2-40B4-BE49-F238E27FC236}">
+                <a16:creationId xmlns:a16="http://schemas.microsoft.com/office/drawing/2014/main" id="{3F54BAC2-B1AE-436C-3895-8B0AD863AE9E}"/>
+              </a:ext>
+            </a:extLst>
+          </p:cNvPr>
+          <p:cNvSpPr txBox="1"/>
+          <p:nvPr/>
+        </p:nvSpPr>
+        <p:spPr>
+          <a:xfrm>
+            <a:off x="1895163" y="1982255"/>
+            <a:ext cx="1630075" cy="307777"/>
+          </a:xfrm>
+          <a:prstGeom prst="rect">
+            <a:avLst/>
+          </a:prstGeom>
+          <a:noFill/>
+        </p:spPr>
+        <p:txBody>
+          <a:bodyPr wrap="square">
+            <a:spAutoFit/>
+          </a:bodyPr>
+          <a:lstStyle/>
+          <a:p>
+            <a:r>
+              <a:rPr lang="es-UY" sz="1400" b="1" noProof="0" dirty="0" err="1">
+                <a:solidFill>
+                  <a:srgbClr val="C9D1D9"/>
+                </a:solidFill>
+                <a:ea typeface="Calibri" pitchFamily="34" charset="-122"/>
+                <a:cs typeface="Calibri" pitchFamily="34" charset="-120"/>
+              </a:rPr>
+              <a:t>Inline</a:t>
+            </a:r>
+            <a:r>
+              <a:rPr lang="es-UY" sz="1400" b="1" noProof="0" dirty="0">
+                <a:solidFill>
+                  <a:srgbClr val="C9D1D9"/>
+                </a:solidFill>
+                <a:ea typeface="Calibri" pitchFamily="34" charset="-122"/>
+                <a:cs typeface="Calibri" pitchFamily="34" charset="-120"/>
+              </a:rPr>
+              <a:t> Chat</a:t>
+            </a:r>
+            <a:endParaRPr lang="es-419" sz="1400" b="1" noProof="0" dirty="0"/>
+          </a:p>
+        </p:txBody>
+      </p:sp>
+      <p:sp>
+        <p:nvSpPr>
+          <p:cNvPr id="7" name="CuadroTexto 6">
+            <a:extLst>
+              <a:ext uri="{FF2B5EF4-FFF2-40B4-BE49-F238E27FC236}">
+                <a16:creationId xmlns:a16="http://schemas.microsoft.com/office/drawing/2014/main" id="{DC6F888D-A72D-B8B1-1A36-AFBB7D872E55}"/>
+              </a:ext>
+            </a:extLst>
+          </p:cNvPr>
+          <p:cNvSpPr txBox="1"/>
+          <p:nvPr/>
+        </p:nvSpPr>
+        <p:spPr>
+          <a:xfrm>
+            <a:off x="262520" y="2235736"/>
+            <a:ext cx="4309480" cy="617733"/>
+          </a:xfrm>
+          <a:prstGeom prst="rect">
+            <a:avLst/>
+          </a:prstGeom>
+          <a:noFill/>
+        </p:spPr>
+        <p:txBody>
+          <a:bodyPr wrap="square">
+            <a:spAutoFit/>
+          </a:bodyPr>
+          <a:lstStyle/>
+          <a:p>
+            <a:pPr>
+              <a:lnSpc>
+                <a:spcPct val="150000"/>
+              </a:lnSpc>
+            </a:pPr>
+            <a:r>
+              <a:rPr lang="es-419" sz="1200" dirty="0">
+                <a:solidFill>
+                  <a:srgbClr val="C9D1D9"/>
+                </a:solidFill>
+                <a:latin typeface="Calibri" pitchFamily="34" charset="0"/>
+                <a:ea typeface="Calibri" pitchFamily="34" charset="-122"/>
+                <a:cs typeface="Calibri" pitchFamily="34" charset="-120"/>
+              </a:rPr>
+              <a:t>Para realizar consultas sobre una sección de código </a:t>
+            </a:r>
+            <a:r>
+              <a:rPr lang="es-419" sz="1200" dirty="0">
+                <a:highlight>
+                  <a:srgbClr val="C0C0C0"/>
+                </a:highlight>
+                <a:latin typeface="Calibri" pitchFamily="34" charset="0"/>
+                <a:ea typeface="Calibri" pitchFamily="34" charset="-122"/>
+                <a:cs typeface="Calibri" pitchFamily="34" charset="-120"/>
+              </a:rPr>
+              <a:t>CTRL + I </a:t>
+            </a:r>
+            <a:r>
+              <a:rPr lang="es-419" sz="1200" dirty="0">
+                <a:latin typeface="Calibri" pitchFamily="34" charset="0"/>
+                <a:ea typeface="Calibri" pitchFamily="34" charset="-122"/>
+                <a:cs typeface="Calibri" pitchFamily="34" charset="-120"/>
+              </a:rPr>
+              <a:t> </a:t>
+            </a:r>
+            <a:r>
+              <a:rPr lang="es-419" sz="1200" dirty="0">
+                <a:solidFill>
+                  <a:srgbClr val="C9D1D9"/>
+                </a:solidFill>
+                <a:latin typeface="Calibri" pitchFamily="34" charset="0"/>
+                <a:ea typeface="Calibri" pitchFamily="34" charset="-122"/>
+                <a:cs typeface="Calibri" pitchFamily="34" charset="-120"/>
+              </a:rPr>
+              <a:t>o Click derecho -&gt; </a:t>
+            </a:r>
+            <a:r>
+              <a:rPr lang="es-419" sz="1200" dirty="0" err="1">
+                <a:solidFill>
+                  <a:srgbClr val="C9D1D9"/>
+                </a:solidFill>
+                <a:latin typeface="Calibri" pitchFamily="34" charset="0"/>
+                <a:ea typeface="Calibri" pitchFamily="34" charset="-122"/>
+                <a:cs typeface="Calibri" pitchFamily="34" charset="-120"/>
+              </a:rPr>
+              <a:t>Inline</a:t>
+            </a:r>
+            <a:r>
+              <a:rPr lang="es-419" sz="1200" dirty="0">
+                <a:solidFill>
+                  <a:srgbClr val="C9D1D9"/>
+                </a:solidFill>
+                <a:latin typeface="Calibri" pitchFamily="34" charset="0"/>
+                <a:ea typeface="Calibri" pitchFamily="34" charset="-122"/>
+                <a:cs typeface="Calibri" pitchFamily="34" charset="-120"/>
+              </a:rPr>
+              <a:t> Chat</a:t>
+            </a:r>
+            <a:endParaRPr lang="es-419" sz="1200" noProof="0" dirty="0"/>
+          </a:p>
+        </p:txBody>
+      </p:sp>
     </p:spTree>
     <p:extLst>
       <p:ext uri="{BB962C8B-B14F-4D97-AF65-F5344CB8AC3E}">

</xml_diff>